<commit_message>
release: 0.5.0 — docs for data, ingest, MCP, install and sync; page checks for sources; chart from with options; YAML keeps flow lists
Co-Authored-By: Claude Opus 5.5 <noreply@anthropic.com>
</commit_message>
<xml_diff>
--- a/docs/showcase/slidecraft-overview.pptx
+++ b/docs/showcase/slidecraft-overview.pptx
@@ -2236,7 +2236,7 @@
       </p:grpSpPr>
       <p:sp>
         <p:nvSpPr>
-          <p:cNvPr id="3" name="SlideCraft Title"/>
+          <p:cNvPr id="3" name="SlideCraft Title sc:cover/title"/>
           <p:cNvSpPr>
             <a:spLocks xmlns:a="http://schemas.openxmlformats.org/drawingml/2006/main" noGrp="1"/>
           </p:cNvSpPr>
@@ -2282,7 +2282,7 @@
       </p:sp>
       <p:sp>
         <p:nvSpPr>
-          <p:cNvPr id="2" name="Text 0"/>
+          <p:cNvPr id="2" name="sc:cover/kicker"/>
           <p:cNvSpPr txBox="1"/>
           <p:nvPr/>
         </p:nvSpPr>
@@ -2324,7 +2324,7 @@
       </p:sp>
       <p:sp>
         <p:nvSpPr>
-          <p:cNvPr id="4" name="Text 2"/>
+          <p:cNvPr id="4" name="sc:cover/subtitle"/>
           <p:cNvSpPr txBox="1"/>
           <p:nvPr/>
         </p:nvSpPr>
@@ -2389,7 +2389,7 @@
       </p:sp>
       <p:sp>
         <p:nvSpPr>
-          <p:cNvPr id="6" name="Text 4"/>
+          <p:cNvPr id="6" name="sc:cover/presenter"/>
           <p:cNvSpPr txBox="1"/>
           <p:nvPr/>
         </p:nvSpPr>
@@ -2456,7 +2456,7 @@
       </p:grpSpPr>
       <p:sp>
         <p:nvSpPr>
-          <p:cNvPr id="3" name="SlideCraft Title"/>
+          <p:cNvPr id="3" name="SlideCraft Title sc:brand/title"/>
           <p:cNvSpPr>
             <a:spLocks xmlns:a="http://schemas.openxmlformats.org/drawingml/2006/main" noGrp="1"/>
           </p:cNvSpPr>
@@ -2502,7 +2502,7 @@
       </p:sp>
       <p:sp>
         <p:nvSpPr>
-          <p:cNvPr id="2" name="Text 0"/>
+          <p:cNvPr id="2" name="sc:brand/tracker"/>
           <p:cNvSpPr txBox="1"/>
           <p:nvPr/>
         </p:nvSpPr>
@@ -2567,7 +2567,7 @@
       </p:sp>
       <p:sp>
         <p:nvSpPr>
-          <p:cNvPr id="5" name="Text 3"/>
+          <p:cNvPr id="5" name="sc:brand/points/0/heading"/>
           <p:cNvSpPr txBox="1"/>
           <p:nvPr/>
         </p:nvSpPr>
@@ -2632,7 +2632,7 @@
       </p:sp>
       <p:sp>
         <p:nvSpPr>
-          <p:cNvPr id="7" name="Text 5"/>
+          <p:cNvPr id="7" name="sc:brand/points/1/heading"/>
           <p:cNvSpPr txBox="1"/>
           <p:nvPr/>
         </p:nvSpPr>
@@ -2697,7 +2697,7 @@
       </p:sp>
       <p:sp>
         <p:nvSpPr>
-          <p:cNvPr id="9" name="Text 7"/>
+          <p:cNvPr id="9" name="sc:brand/points/2/heading"/>
           <p:cNvSpPr txBox="1"/>
           <p:nvPr/>
         </p:nvSpPr>
@@ -2739,7 +2739,7 @@
       </p:sp>
       <p:sp>
         <p:nvSpPr>
-          <p:cNvPr id="10" name="Text 8"/>
+          <p:cNvPr id="10" name="sc:brand/points/0/body"/>
           <p:cNvSpPr txBox="1"/>
           <p:nvPr/>
         </p:nvSpPr>
@@ -2781,7 +2781,7 @@
       </p:sp>
       <p:sp>
         <p:nvSpPr>
-          <p:cNvPr id="11" name="Text 9"/>
+          <p:cNvPr id="11" name="sc:brand/points/1/body"/>
           <p:cNvSpPr txBox="1"/>
           <p:nvPr/>
         </p:nvSpPr>
@@ -2823,7 +2823,7 @@
       </p:sp>
       <p:sp>
         <p:nvSpPr>
-          <p:cNvPr id="12" name="Text 10"/>
+          <p:cNvPr id="12" name="sc:brand/points/2/body"/>
           <p:cNvSpPr txBox="1"/>
           <p:nvPr/>
         </p:nvSpPr>
@@ -2938,7 +2938,7 @@
       </p:grpSpPr>
       <p:sp>
         <p:nvSpPr>
-          <p:cNvPr id="3" name="SlideCraft Title"/>
+          <p:cNvPr id="3" name="SlideCraft Title sc:start/title"/>
           <p:cNvSpPr>
             <a:spLocks xmlns:a="http://schemas.openxmlformats.org/drawingml/2006/main" noGrp="1"/>
           </p:cNvSpPr>
@@ -2984,7 +2984,7 @@
       </p:sp>
       <p:sp>
         <p:nvSpPr>
-          <p:cNvPr id="2" name="Text 0"/>
+          <p:cNvPr id="2" name="sc:start/tracker"/>
           <p:cNvSpPr txBox="1"/>
           <p:nvPr/>
         </p:nvSpPr>
@@ -3111,7 +3111,7 @@
       </p:sp>
       <p:sp>
         <p:nvSpPr>
-          <p:cNvPr id="7" name="Text 5"/>
+          <p:cNvPr id="7" name="sc:start/decision"/>
           <p:cNvSpPr txBox="1"/>
           <p:nvPr/>
         </p:nvSpPr>
@@ -3218,7 +3218,7 @@
       </p:sp>
       <p:sp>
         <p:nvSpPr>
-          <p:cNvPr id="10" name="Text 8"/>
+          <p:cNvPr id="10" name="sc:start/steps/0/action"/>
           <p:cNvSpPr txBox="1"/>
           <p:nvPr/>
         </p:nvSpPr>
@@ -3260,7 +3260,7 @@
       </p:sp>
       <p:sp>
         <p:nvSpPr>
-          <p:cNvPr id="11" name="Text 9"/>
+          <p:cNvPr id="11" name="sc:start/steps/0/owner"/>
           <p:cNvSpPr txBox="1"/>
           <p:nvPr/>
         </p:nvSpPr>
@@ -3367,7 +3367,7 @@
       </p:sp>
       <p:sp>
         <p:nvSpPr>
-          <p:cNvPr id="14" name="Text 12"/>
+          <p:cNvPr id="14" name="sc:start/steps/1/action"/>
           <p:cNvSpPr txBox="1"/>
           <p:nvPr/>
         </p:nvSpPr>
@@ -3409,7 +3409,7 @@
       </p:sp>
       <p:sp>
         <p:nvSpPr>
-          <p:cNvPr id="15" name="Text 13"/>
+          <p:cNvPr id="15" name="sc:start/steps/1/owner"/>
           <p:cNvSpPr txBox="1"/>
           <p:nvPr/>
         </p:nvSpPr>
@@ -3516,7 +3516,7 @@
       </p:sp>
       <p:sp>
         <p:nvSpPr>
-          <p:cNvPr id="18" name="Text 16"/>
+          <p:cNvPr id="18" name="sc:start/steps/2/action"/>
           <p:cNvSpPr txBox="1"/>
           <p:nvPr/>
         </p:nvSpPr>
@@ -3558,7 +3558,7 @@
       </p:sp>
       <p:sp>
         <p:nvSpPr>
-          <p:cNvPr id="19" name="Text 17"/>
+          <p:cNvPr id="19" name="sc:start/steps/2/owner"/>
           <p:cNvSpPr txBox="1"/>
           <p:nvPr/>
         </p:nvSpPr>
@@ -3665,7 +3665,7 @@
       </p:sp>
       <p:sp>
         <p:nvSpPr>
-          <p:cNvPr id="22" name="Text 20"/>
+          <p:cNvPr id="22" name="sc:start/steps/3/action"/>
           <p:cNvSpPr txBox="1"/>
           <p:nvPr/>
         </p:nvSpPr>
@@ -3707,7 +3707,7 @@
       </p:sp>
       <p:sp>
         <p:nvSpPr>
-          <p:cNvPr id="23" name="Text 21"/>
+          <p:cNvPr id="23" name="sc:start/steps/3/owner"/>
           <p:cNvSpPr txBox="1"/>
           <p:nvPr/>
         </p:nvSpPr>
@@ -3845,7 +3845,7 @@
       </p:grpSpPr>
       <p:sp>
         <p:nvSpPr>
-          <p:cNvPr id="2" name="SlideCraft Title"/>
+          <p:cNvPr id="2" name="SlideCraft Title sc:close/title"/>
           <p:cNvSpPr>
             <a:spLocks xmlns:a="http://schemas.openxmlformats.org/drawingml/2006/main" noGrp="1"/>
           </p:cNvSpPr>
@@ -3891,7 +3891,7 @@
       </p:sp>
       <p:sp>
         <p:nvSpPr>
-          <p:cNvPr id="3" name="Text 1"/>
+          <p:cNvPr id="3" name="sc:close/subtitle"/>
           <p:cNvSpPr txBox="1"/>
           <p:nvPr/>
         </p:nvSpPr>
@@ -3956,7 +3956,7 @@
       </p:sp>
       <p:sp>
         <p:nvSpPr>
-          <p:cNvPr id="5" name="Text 3"/>
+          <p:cNvPr id="5" name="sc:close/contact"/>
           <p:cNvSpPr txBox="1"/>
           <p:nvPr/>
         </p:nvSpPr>
@@ -4043,7 +4043,7 @@
       </p:grpSpPr>
       <p:sp>
         <p:nvSpPr>
-          <p:cNvPr id="2" name="SlideCraft Title"/>
+          <p:cNvPr id="2" name="SlideCraft Title sc:problem/title"/>
           <p:cNvSpPr>
             <a:spLocks xmlns:a="http://schemas.openxmlformats.org/drawingml/2006/main" noGrp="1"/>
           </p:cNvSpPr>
@@ -4089,7 +4089,7 @@
       </p:sp>
       <p:sp>
         <p:nvSpPr>
-          <p:cNvPr id="3" name="Text 1"/>
+          <p:cNvPr id="3" name="sc:problem/support"/>
           <p:cNvSpPr txBox="1"/>
           <p:nvPr/>
         </p:nvSpPr>
@@ -4227,7 +4227,7 @@
       </p:grpSpPr>
       <p:sp>
         <p:nvSpPr>
-          <p:cNvPr id="3" name="SlideCraft Title"/>
+          <p:cNvPr id="3" name="SlideCraft Title sc:summary/title"/>
           <p:cNvSpPr>
             <a:spLocks xmlns:a="http://schemas.openxmlformats.org/drawingml/2006/main" noGrp="1"/>
           </p:cNvSpPr>
@@ -4273,7 +4273,7 @@
       </p:sp>
       <p:sp>
         <p:nvSpPr>
-          <p:cNvPr id="2" name="Text 0"/>
+          <p:cNvPr id="2" name="sc:summary/tracker"/>
           <p:cNvSpPr txBox="1"/>
           <p:nvPr/>
         </p:nvSpPr>
@@ -4335,7 +4335,7 @@
       </p:sp>
       <p:sp>
         <p:nvSpPr>
-          <p:cNvPr id="5" name="Text 3"/>
+          <p:cNvPr id="5" name="sc:summary/ask"/>
           <p:cNvSpPr txBox="1"/>
           <p:nvPr/>
         </p:nvSpPr>
@@ -4436,7 +4436,7 @@
       </p:sp>
       <p:sp>
         <p:nvSpPr>
-          <p:cNvPr id="7" name="Text 5"/>
+          <p:cNvPr id="7" name="sc:summary/situation"/>
           <p:cNvSpPr txBox="1"/>
           <p:nvPr/>
         </p:nvSpPr>
@@ -4543,7 +4543,7 @@
       </p:sp>
       <p:sp>
         <p:nvSpPr>
-          <p:cNvPr id="10" name="Text 8"/>
+          <p:cNvPr id="10" name="sc:summary/complication"/>
           <p:cNvSpPr txBox="1"/>
           <p:nvPr/>
         </p:nvSpPr>
@@ -4650,7 +4650,7 @@
       </p:sp>
       <p:sp>
         <p:nvSpPr>
-          <p:cNvPr id="13" name="Text 11"/>
+          <p:cNvPr id="13" name="sc:summary/resolution"/>
           <p:cNvSpPr txBox="1"/>
           <p:nvPr/>
         </p:nvSpPr>
@@ -4765,7 +4765,7 @@
       </p:grpSpPr>
       <p:sp>
         <p:nvSpPr>
-          <p:cNvPr id="3" name="SlideCraft Title"/>
+          <p:cNvPr id="3" name="SlideCraft Title sc:how/title"/>
           <p:cNvSpPr>
             <a:spLocks xmlns:a="http://schemas.openxmlformats.org/drawingml/2006/main" noGrp="1"/>
           </p:cNvSpPr>
@@ -4811,7 +4811,7 @@
       </p:sp>
       <p:sp>
         <p:nvSpPr>
-          <p:cNvPr id="2" name="Text 0"/>
+          <p:cNvPr id="2" name="sc:how/tracker"/>
           <p:cNvSpPr txBox="1"/>
           <p:nvPr/>
         </p:nvSpPr>
@@ -4853,7 +4853,7 @@
       </p:sp>
       <p:sp>
         <p:nvSpPr>
-          <p:cNvPr id="4" name="Text 2"/>
+          <p:cNvPr id="4" name="sc:how/lead"/>
           <p:cNvSpPr txBox="1"/>
           <p:nvPr/>
         </p:nvSpPr>
@@ -4939,7 +4939,7 @@
       </p:sp>
       <p:sp>
         <p:nvSpPr>
-          <p:cNvPr id="6" name="Text 4"/>
+          <p:cNvPr id="6" name="sc:how/steps/0/title"/>
           <p:cNvSpPr txBox="1"/>
           <p:nvPr/>
         </p:nvSpPr>
@@ -4981,7 +4981,7 @@
       </p:sp>
       <p:sp>
         <p:nvSpPr>
-          <p:cNvPr id="7" name="Text 5"/>
+          <p:cNvPr id="7" name="sc:how/steps/0/body"/>
           <p:cNvSpPr txBox="1"/>
           <p:nvPr/>
         </p:nvSpPr>
@@ -5070,7 +5070,7 @@
       </p:sp>
       <p:sp>
         <p:nvSpPr>
-          <p:cNvPr id="9" name="Text 7"/>
+          <p:cNvPr id="9" name="sc:how/steps/1/title"/>
           <p:cNvSpPr txBox="1"/>
           <p:nvPr/>
         </p:nvSpPr>
@@ -5112,7 +5112,7 @@
       </p:sp>
       <p:sp>
         <p:nvSpPr>
-          <p:cNvPr id="10" name="Text 8"/>
+          <p:cNvPr id="10" name="sc:how/steps/1/body"/>
           <p:cNvSpPr txBox="1"/>
           <p:nvPr/>
         </p:nvSpPr>
@@ -5201,7 +5201,7 @@
       </p:sp>
       <p:sp>
         <p:nvSpPr>
-          <p:cNvPr id="12" name="Text 10"/>
+          <p:cNvPr id="12" name="sc:how/steps/2/title"/>
           <p:cNvSpPr txBox="1"/>
           <p:nvPr/>
         </p:nvSpPr>
@@ -5243,7 +5243,7 @@
       </p:sp>
       <p:sp>
         <p:nvSpPr>
-          <p:cNvPr id="13" name="Text 11"/>
+          <p:cNvPr id="13" name="sc:how/steps/2/body"/>
           <p:cNvSpPr txBox="1"/>
           <p:nvPr/>
         </p:nvSpPr>
@@ -5332,7 +5332,7 @@
       </p:sp>
       <p:sp>
         <p:nvSpPr>
-          <p:cNvPr id="15" name="Text 13"/>
+          <p:cNvPr id="15" name="sc:how/steps/3/title"/>
           <p:cNvSpPr txBox="1"/>
           <p:nvPr/>
         </p:nvSpPr>
@@ -5374,7 +5374,7 @@
       </p:sp>
       <p:sp>
         <p:nvSpPr>
-          <p:cNvPr id="16" name="Text 14"/>
+          <p:cNvPr id="16" name="sc:how/steps/3/body"/>
           <p:cNvSpPr txBox="1"/>
           <p:nvPr/>
         </p:nvSpPr>
@@ -5463,7 +5463,7 @@
       </p:sp>
       <p:sp>
         <p:nvSpPr>
-          <p:cNvPr id="18" name="Text 16"/>
+          <p:cNvPr id="18" name="sc:how/steps/4/title"/>
           <p:cNvSpPr txBox="1"/>
           <p:nvPr/>
         </p:nvSpPr>
@@ -5505,7 +5505,7 @@
       </p:sp>
       <p:sp>
         <p:nvSpPr>
-          <p:cNvPr id="19" name="Text 17"/>
+          <p:cNvPr id="19" name="sc:how/steps/4/body"/>
           <p:cNvSpPr txBox="1"/>
           <p:nvPr/>
         </p:nvSpPr>
@@ -5620,7 +5620,7 @@
       </p:grpSpPr>
       <p:sp>
         <p:nvSpPr>
-          <p:cNvPr id="3" name="SlideCraft Title"/>
+          <p:cNvPr id="3" name="SlideCraft Title sc:before-after/title"/>
           <p:cNvSpPr>
             <a:spLocks xmlns:a="http://schemas.openxmlformats.org/drawingml/2006/main" noGrp="1"/>
           </p:cNvSpPr>
@@ -5666,7 +5666,7 @@
       </p:sp>
       <p:sp>
         <p:nvSpPr>
-          <p:cNvPr id="2" name="Text 0"/>
+          <p:cNvPr id="2" name="sc:before-after/tracker"/>
           <p:cNvSpPr txBox="1"/>
           <p:nvPr/>
         </p:nvSpPr>
@@ -5728,7 +5728,7 @@
       </p:sp>
       <p:sp>
         <p:nvSpPr>
-          <p:cNvPr id="5" name="Text 3"/>
+          <p:cNvPr id="5" name="sc:before-after/before/label"/>
           <p:cNvSpPr txBox="1"/>
           <p:nvPr/>
         </p:nvSpPr>
@@ -5770,7 +5770,7 @@
       </p:sp>
       <p:sp>
         <p:nvSpPr>
-          <p:cNvPr id="6" name="Text 4"/>
+          <p:cNvPr id="6" name="sc:before-after/before/items"/>
           <p:cNvSpPr txBox="1"/>
           <p:nvPr/>
         </p:nvSpPr>
@@ -5963,7 +5963,7 @@
       </p:sp>
       <p:sp>
         <p:nvSpPr>
-          <p:cNvPr id="10" name="Text 8"/>
+          <p:cNvPr id="10" name="sc:before-after/after/label"/>
           <p:cNvSpPr txBox="1"/>
           <p:nvPr/>
         </p:nvSpPr>
@@ -6005,7 +6005,7 @@
       </p:sp>
       <p:sp>
         <p:nvSpPr>
-          <p:cNvPr id="11" name="Text 9"/>
+          <p:cNvPr id="11" name="sc:before-after/after/items"/>
           <p:cNvSpPr txBox="1"/>
           <p:nvPr/>
         </p:nvSpPr>
@@ -6193,7 +6193,7 @@
       </p:grpSpPr>
       <p:sp>
         <p:nvSpPr>
-          <p:cNvPr id="3" name="SlideCraft Title"/>
+          <p:cNvPr id="3" name="SlideCraft Title sc:who/title"/>
           <p:cNvSpPr>
             <a:spLocks xmlns:a="http://schemas.openxmlformats.org/drawingml/2006/main" noGrp="1"/>
           </p:cNvSpPr>
@@ -6239,7 +6239,7 @@
       </p:sp>
       <p:sp>
         <p:nvSpPr>
-          <p:cNvPr id="2" name="Text 0"/>
+          <p:cNvPr id="2" name="sc:who/tracker"/>
           <p:cNvSpPr txBox="1"/>
           <p:nvPr/>
         </p:nvSpPr>
@@ -6321,7 +6321,7 @@
       </p:sp>
       <p:sp>
         <p:nvSpPr>
-          <p:cNvPr id="6" name="Text 4"/>
+          <p:cNvPr id="6" name="sc:who/points/0/heading"/>
           <p:cNvSpPr txBox="1"/>
           <p:nvPr/>
         </p:nvSpPr>
@@ -6403,7 +6403,7 @@
       </p:sp>
       <p:sp>
         <p:nvSpPr>
-          <p:cNvPr id="9" name="Text 7"/>
+          <p:cNvPr id="9" name="sc:who/points/1/heading"/>
           <p:cNvSpPr txBox="1"/>
           <p:nvPr/>
         </p:nvSpPr>
@@ -6485,7 +6485,7 @@
       </p:sp>
       <p:sp>
         <p:nvSpPr>
-          <p:cNvPr id="12" name="Text 10"/>
+          <p:cNvPr id="12" name="sc:who/points/2/heading"/>
           <p:cNvSpPr txBox="1"/>
           <p:nvPr/>
         </p:nvSpPr>
@@ -6567,7 +6567,7 @@
       </p:sp>
       <p:sp>
         <p:nvSpPr>
-          <p:cNvPr id="15" name="Text 13"/>
+          <p:cNvPr id="15" name="sc:who/points/3/heading"/>
           <p:cNvSpPr txBox="1"/>
           <p:nvPr/>
         </p:nvSpPr>
@@ -6609,7 +6609,7 @@
       </p:sp>
       <p:sp>
         <p:nvSpPr>
-          <p:cNvPr id="16" name="Text 14"/>
+          <p:cNvPr id="16" name="sc:who/points/0/body"/>
           <p:cNvSpPr txBox="1"/>
           <p:nvPr/>
         </p:nvSpPr>
@@ -6651,7 +6651,7 @@
       </p:sp>
       <p:sp>
         <p:nvSpPr>
-          <p:cNvPr id="17" name="Text 15"/>
+          <p:cNvPr id="17" name="sc:who/points/1/body"/>
           <p:cNvSpPr txBox="1"/>
           <p:nvPr/>
         </p:nvSpPr>
@@ -6693,7 +6693,7 @@
       </p:sp>
       <p:sp>
         <p:nvSpPr>
-          <p:cNvPr id="18" name="Text 16"/>
+          <p:cNvPr id="18" name="sc:who/points/2/body"/>
           <p:cNvSpPr txBox="1"/>
           <p:nvPr/>
         </p:nvSpPr>
@@ -6735,7 +6735,7 @@
       </p:sp>
       <p:sp>
         <p:nvSpPr>
-          <p:cNvPr id="19" name="Text 17"/>
+          <p:cNvPr id="19" name="sc:who/points/3/body"/>
           <p:cNvSpPr txBox="1"/>
           <p:nvPr/>
         </p:nvSpPr>
@@ -6850,7 +6850,7 @@
       </p:grpSpPr>
       <p:sp>
         <p:nvSpPr>
-          <p:cNvPr id="3" name="SlideCraft Title"/>
+          <p:cNvPr id="3" name="SlideCraft Title sc:tasks/title"/>
           <p:cNvSpPr>
             <a:spLocks xmlns:a="http://schemas.openxmlformats.org/drawingml/2006/main" noGrp="1"/>
           </p:cNvSpPr>
@@ -6896,7 +6896,7 @@
       </p:sp>
       <p:sp>
         <p:nvSpPr>
-          <p:cNvPr id="2" name="Text 0"/>
+          <p:cNvPr id="2" name="sc:tasks/tracker"/>
           <p:cNvSpPr txBox="1"/>
           <p:nvPr/>
         </p:nvSpPr>
@@ -8185,7 +8185,7 @@
       </p:graphicFrame>
       <p:sp>
         <p:nvSpPr>
-          <p:cNvPr id="5" name="Text 2"/>
+          <p:cNvPr id="5" name="sc:tasks/note"/>
           <p:cNvSpPr txBox="1"/>
           <p:nvPr/>
         </p:nvSpPr>
@@ -8227,7 +8227,7 @@
       </p:sp>
       <p:sp>
         <p:nvSpPr>
-          <p:cNvPr id="6" name="Text 3"/>
+          <p:cNvPr id="6" name="sc:tasks/sources"/>
           <p:cNvSpPr txBox="1"/>
           <p:nvPr/>
         </p:nvSpPr>
@@ -8285,24 +8285,7 @@
                   </a:extLst>
                 </a:hlinkClick>
               </a:rPr>
-              <a:t>SlideCraft 0.4 release notes and test suite</a:t>
-            </a:r>
-            <a:pPr algn="l" indent="0" marL="0">
-              <a:lnSpc>
-                <a:spcPts val="960"/>
-              </a:lnSpc>
-              <a:buNone/>
-            </a:pPr>
-            <a:r>
-              <a:rPr lang="en-US" sz="800" dirty="0">
-                <a:solidFill>
-                  <a:srgbClr val="5B6B7F"/>
-                </a:solidFill>
-                <a:latin typeface="Arial" pitchFamily="34" charset="0"/>
-                <a:ea typeface="Arial" pitchFamily="34" charset="-122"/>
-                <a:cs typeface="Arial" pitchFamily="34" charset="-120"/>
-              </a:rPr>
-              <a:t> (Oct 2026)</a:t>
+              <a:t>SlideCraft 0.4 release notes and test suite (Oct 2026)</a:t>
             </a:r>
             <a:endParaRPr lang="en-US" sz="800" dirty="0"/>
           </a:p>
@@ -8383,7 +8366,7 @@
       </p:grpSpPr>
       <p:sp>
         <p:nvSpPr>
-          <p:cNvPr id="3" name="SlideCraft Title"/>
+          <p:cNvPr id="3" name="SlideCraft Title sc:kit/title"/>
           <p:cNvSpPr>
             <a:spLocks xmlns:a="http://schemas.openxmlformats.org/drawingml/2006/main" noGrp="1"/>
           </p:cNvSpPr>
@@ -8429,7 +8412,7 @@
       </p:sp>
       <p:sp>
         <p:nvSpPr>
-          <p:cNvPr id="2" name="Text 0"/>
+          <p:cNvPr id="2" name="sc:kit/tracker"/>
           <p:cNvSpPr txBox="1"/>
           <p:nvPr/>
         </p:nvSpPr>
@@ -8571,7 +8554,7 @@
       </p:sp>
       <p:sp>
         <p:nvSpPr>
-          <p:cNvPr id="9" name="Text 7"/>
+          <p:cNvPr id="9" name="sc:kit/tiles/0/label"/>
           <p:cNvSpPr txBox="1"/>
           <p:nvPr/>
         </p:nvSpPr>
@@ -8613,7 +8596,7 @@
       </p:sp>
       <p:sp>
         <p:nvSpPr>
-          <p:cNvPr id="10" name="Text 8"/>
+          <p:cNvPr id="10" name="sc:kit/tiles/1/label"/>
           <p:cNvSpPr txBox="1"/>
           <p:nvPr/>
         </p:nvSpPr>
@@ -8655,7 +8638,7 @@
       </p:sp>
       <p:sp>
         <p:nvSpPr>
-          <p:cNvPr id="11" name="Text 9"/>
+          <p:cNvPr id="11" name="sc:kit/tiles/2/label"/>
           <p:cNvSpPr txBox="1"/>
           <p:nvPr/>
         </p:nvSpPr>
@@ -8697,7 +8680,7 @@
       </p:sp>
       <p:sp>
         <p:nvSpPr>
-          <p:cNvPr id="12" name="Text 10"/>
+          <p:cNvPr id="12" name="sc:kit/tiles/3/label"/>
           <p:cNvSpPr txBox="1"/>
           <p:nvPr/>
         </p:nvSpPr>
@@ -8739,7 +8722,7 @@
       </p:sp>
       <p:sp>
         <p:nvSpPr>
-          <p:cNvPr id="13" name="Text 11"/>
+          <p:cNvPr id="13" name="sc:kit/tiles/0/value"/>
           <p:cNvSpPr txBox="1"/>
           <p:nvPr/>
         </p:nvSpPr>
@@ -8804,7 +8787,7 @@
       </p:sp>
       <p:sp>
         <p:nvSpPr>
-          <p:cNvPr id="15" name="Text 13"/>
+          <p:cNvPr id="15" name="sc:kit/tiles/0/note"/>
           <p:cNvSpPr txBox="1"/>
           <p:nvPr/>
         </p:nvSpPr>
@@ -8846,7 +8829,7 @@
       </p:sp>
       <p:sp>
         <p:nvSpPr>
-          <p:cNvPr id="16" name="Text 14"/>
+          <p:cNvPr id="16" name="sc:kit/tiles/1/value"/>
           <p:cNvSpPr txBox="1"/>
           <p:nvPr/>
         </p:nvSpPr>
@@ -8911,7 +8894,7 @@
       </p:sp>
       <p:sp>
         <p:nvSpPr>
-          <p:cNvPr id="18" name="Text 16"/>
+          <p:cNvPr id="18" name="sc:kit/tiles/1/note"/>
           <p:cNvSpPr txBox="1"/>
           <p:nvPr/>
         </p:nvSpPr>
@@ -8953,7 +8936,7 @@
       </p:sp>
       <p:sp>
         <p:nvSpPr>
-          <p:cNvPr id="19" name="Text 17"/>
+          <p:cNvPr id="19" name="sc:kit/tiles/2/value"/>
           <p:cNvSpPr txBox="1"/>
           <p:nvPr/>
         </p:nvSpPr>
@@ -9018,7 +9001,7 @@
       </p:sp>
       <p:sp>
         <p:nvSpPr>
-          <p:cNvPr id="21" name="Text 19"/>
+          <p:cNvPr id="21" name="sc:kit/tiles/2/note"/>
           <p:cNvSpPr txBox="1"/>
           <p:nvPr/>
         </p:nvSpPr>
@@ -9060,7 +9043,7 @@
       </p:sp>
       <p:sp>
         <p:nvSpPr>
-          <p:cNvPr id="22" name="Text 20"/>
+          <p:cNvPr id="22" name="sc:kit/tiles/3/value"/>
           <p:cNvSpPr txBox="1"/>
           <p:nvPr/>
         </p:nvSpPr>
@@ -9125,7 +9108,7 @@
       </p:sp>
       <p:sp>
         <p:nvSpPr>
-          <p:cNvPr id="24" name="Text 22"/>
+          <p:cNvPr id="24" name="sc:kit/tiles/3/note"/>
           <p:cNvSpPr txBox="1"/>
           <p:nvPr/>
         </p:nvSpPr>
@@ -9167,7 +9150,7 @@
       </p:sp>
       <p:sp>
         <p:nvSpPr>
-          <p:cNvPr id="25" name="Text 23"/>
+          <p:cNvPr id="25" name="sc:kit/sources"/>
           <p:cNvSpPr txBox="1"/>
           <p:nvPr/>
         </p:nvSpPr>
@@ -9225,24 +9208,7 @@
                   </a:extLst>
                 </a:hlinkClick>
               </a:rPr>
-              <a:t>SlideCraft 0.4 release notes and test suite</a:t>
-            </a:r>
-            <a:pPr algn="l" indent="0" marL="0">
-              <a:lnSpc>
-                <a:spcPts val="960"/>
-              </a:lnSpc>
-              <a:buNone/>
-            </a:pPr>
-            <a:r>
-              <a:rPr lang="en-US" sz="800" dirty="0">
-                <a:solidFill>
-                  <a:srgbClr val="5B6B7F"/>
-                </a:solidFill>
-                <a:latin typeface="Arial" pitchFamily="34" charset="0"/>
-                <a:ea typeface="Arial" pitchFamily="34" charset="-122"/>
-                <a:cs typeface="Arial" pitchFamily="34" charset="-120"/>
-              </a:rPr>
-              <a:t> (Oct 2026)</a:t>
+              <a:t>SlideCraft 0.4 release notes and test suite (Oct 2026)</a:t>
             </a:r>
             <a:endParaRPr lang="en-US" sz="800" dirty="0"/>
           </a:p>
@@ -9323,7 +9289,7 @@
       </p:grpSpPr>
       <p:sp>
         <p:nvSpPr>
-          <p:cNvPr id="3" name="SlideCraft Title"/>
+          <p:cNvPr id="3" name="SlideCraft Title sc:quality/title"/>
           <p:cNvSpPr>
             <a:spLocks xmlns:a="http://schemas.openxmlformats.org/drawingml/2006/main" noGrp="1"/>
           </p:cNvSpPr>
@@ -9369,7 +9335,7 @@
       </p:sp>
       <p:sp>
         <p:nvSpPr>
-          <p:cNvPr id="2" name="Text 0"/>
+          <p:cNvPr id="2" name="sc:quality/tracker"/>
           <p:cNvSpPr txBox="1"/>
           <p:nvPr/>
         </p:nvSpPr>
@@ -9539,7 +9505,7 @@
       </p:sp>
       <p:sp>
         <p:nvSpPr>
-          <p:cNvPr id="8" name="Text 6"/>
+          <p:cNvPr id="8" name="sc:quality/steps/0/check"/>
           <p:cNvSpPr txBox="1"/>
           <p:nvPr/>
         </p:nvSpPr>
@@ -9581,7 +9547,7 @@
       </p:sp>
       <p:sp>
         <p:nvSpPr>
-          <p:cNvPr id="9" name="Text 7"/>
+          <p:cNvPr id="9" name="sc:quality/steps/0/finding"/>
           <p:cNvSpPr txBox="1"/>
           <p:nvPr/>
         </p:nvSpPr>
@@ -9646,7 +9612,7 @@
       </p:sp>
       <p:sp>
         <p:nvSpPr>
-          <p:cNvPr id="11" name="Text 9"/>
+          <p:cNvPr id="11" name="sc:quality/steps/0/source"/>
           <p:cNvSpPr txBox="1"/>
           <p:nvPr/>
         </p:nvSpPr>
@@ -9854,7 +9820,7 @@
       </p:sp>
       <p:sp>
         <p:nvSpPr>
-          <p:cNvPr id="17" name="Text 15"/>
+          <p:cNvPr id="17" name="sc:quality/steps/1/check"/>
           <p:cNvSpPr txBox="1"/>
           <p:nvPr/>
         </p:nvSpPr>
@@ -9896,7 +9862,7 @@
       </p:sp>
       <p:sp>
         <p:nvSpPr>
-          <p:cNvPr id="18" name="Text 16"/>
+          <p:cNvPr id="18" name="sc:quality/steps/1/finding"/>
           <p:cNvSpPr txBox="1"/>
           <p:nvPr/>
         </p:nvSpPr>
@@ -9961,7 +9927,7 @@
       </p:sp>
       <p:sp>
         <p:nvSpPr>
-          <p:cNvPr id="20" name="Text 18"/>
+          <p:cNvPr id="20" name="sc:quality/steps/1/source"/>
           <p:cNvSpPr txBox="1"/>
           <p:nvPr/>
         </p:nvSpPr>
@@ -10169,7 +10135,7 @@
       </p:sp>
       <p:sp>
         <p:nvSpPr>
-          <p:cNvPr id="26" name="Text 24"/>
+          <p:cNvPr id="26" name="sc:quality/steps/2/check"/>
           <p:cNvSpPr txBox="1"/>
           <p:nvPr/>
         </p:nvSpPr>
@@ -10211,7 +10177,7 @@
       </p:sp>
       <p:sp>
         <p:nvSpPr>
-          <p:cNvPr id="27" name="Text 25"/>
+          <p:cNvPr id="27" name="sc:quality/steps/2/finding"/>
           <p:cNvSpPr txBox="1"/>
           <p:nvPr/>
         </p:nvSpPr>
@@ -10276,7 +10242,7 @@
       </p:sp>
       <p:sp>
         <p:nvSpPr>
-          <p:cNvPr id="29" name="Text 27"/>
+          <p:cNvPr id="29" name="sc:quality/steps/2/source"/>
           <p:cNvSpPr txBox="1"/>
           <p:nvPr/>
         </p:nvSpPr>
@@ -10484,7 +10450,7 @@
       </p:sp>
       <p:sp>
         <p:nvSpPr>
-          <p:cNvPr id="35" name="Text 33"/>
+          <p:cNvPr id="35" name="sc:quality/steps/3/check"/>
           <p:cNvSpPr txBox="1"/>
           <p:nvPr/>
         </p:nvSpPr>
@@ -10526,7 +10492,7 @@
       </p:sp>
       <p:sp>
         <p:nvSpPr>
-          <p:cNvPr id="36" name="Text 34"/>
+          <p:cNvPr id="36" name="sc:quality/steps/3/finding"/>
           <p:cNvSpPr txBox="1"/>
           <p:nvPr/>
         </p:nvSpPr>
@@ -10591,7 +10557,7 @@
       </p:sp>
       <p:sp>
         <p:nvSpPr>
-          <p:cNvPr id="38" name="Text 36"/>
+          <p:cNvPr id="38" name="sc:quality/steps/3/source"/>
           <p:cNvSpPr txBox="1"/>
           <p:nvPr/>
         </p:nvSpPr>
@@ -10653,7 +10619,7 @@
       </p:sp>
       <p:sp>
         <p:nvSpPr>
-          <p:cNvPr id="40" name="Text 38"/>
+          <p:cNvPr id="40" name="sc:quality/conclusion"/>
           <p:cNvSpPr txBox="1"/>
           <p:nvPr/>
         </p:nvSpPr>
@@ -10712,7 +10678,7 @@
       </p:sp>
       <p:sp>
         <p:nvSpPr>
-          <p:cNvPr id="41" name="Text 39"/>
+          <p:cNvPr id="41" name="sc:quality/exception"/>
           <p:cNvSpPr txBox="1"/>
           <p:nvPr/>
         </p:nvSpPr>
@@ -10771,7 +10737,7 @@
       </p:sp>
       <p:sp>
         <p:nvSpPr>
-          <p:cNvPr id="42" name="Text 40"/>
+          <p:cNvPr id="42" name="sc:quality/sources"/>
           <p:cNvSpPr txBox="1"/>
           <p:nvPr/>
         </p:nvSpPr>
@@ -10829,7 +10795,7 @@
                   </a:extLst>
                 </a:hlinkClick>
               </a:rPr>
-              <a:t>SlideCraft calibration against Microsoft PowerPoint, 144 strings</a:t>
+              <a:t>SlideCraft calibration against Microsoft PowerPoint, 144 strings (Oct 2026)</a:t>
             </a:r>
             <a:pPr algn="l" indent="0" marL="0">
               <a:lnSpc>
@@ -10846,7 +10812,7 @@
                 <a:ea typeface="Arial" pitchFamily="34" charset="-122"/>
                 <a:cs typeface="Arial" pitchFamily="34" charset="-120"/>
               </a:rPr>
-              <a:t> (Oct 2026); </a:t>
+              <a:t>; </a:t>
             </a:r>
             <a:pPr algn="l" indent="0" marL="0">
               <a:lnSpc>
@@ -10870,24 +10836,7 @@
                   </a:extLst>
                 </a:hlinkClick>
               </a:rPr>
-              <a:t>SlideCraft 0.4 release notes and test suite</a:t>
-            </a:r>
-            <a:pPr algn="l" indent="0" marL="0">
-              <a:lnSpc>
-                <a:spcPts val="960"/>
-              </a:lnSpc>
-              <a:buNone/>
-            </a:pPr>
-            <a:r>
-              <a:rPr lang="en-US" sz="800" dirty="0">
-                <a:solidFill>
-                  <a:srgbClr val="5B6B7F"/>
-                </a:solidFill>
-                <a:latin typeface="Arial" pitchFamily="34" charset="0"/>
-                <a:ea typeface="Arial" pitchFamily="34" charset="-122"/>
-                <a:cs typeface="Arial" pitchFamily="34" charset="-120"/>
-              </a:rPr>
-              <a:t> (Oct 2026)</a:t>
+              <a:t>SlideCraft 0.4 release notes and test suite (Oct 2026)</a:t>
             </a:r>
             <a:endParaRPr lang="en-US" sz="800" dirty="0"/>
           </a:p>

</xml_diff>

<commit_message>
docs(showcase): overview deck cover carries the flow motif; refresh showcase files
Co-Authored-By: Claude Opus 5.5 <noreply@anthropic.com>
</commit_message>
<xml_diff>
--- a/docs/showcase/slidecraft-overview.pptx
+++ b/docs/showcase/slidecraft-overview.pptx
@@ -1305,7 +1305,14 @@
           <a:p>
             <a:r>
               <a:rPr lang="en-US" dirty="0"/>
-              <a:t/>
+              <a:t>[Sources]</a:t>
+            </a:r>
+            <a:endParaRPr lang="en-US" dirty="0"/>
+          </a:p>
+          <a:p>
+            <a:r>
+              <a:rPr lang="en-US" dirty="0"/>
+              <a:t>- SlideCraft 0.4 release notes and test suite — Oct 2026 — https://github.com/eiler2005/slidecraft/blob/main/CHANGELOG.md</a:t>
             </a:r>
             <a:endParaRPr lang="en-US" dirty="0"/>
           </a:p>
@@ -1393,7 +1400,14 @@
           <a:p>
             <a:r>
               <a:rPr lang="en-US" dirty="0"/>
-              <a:t/>
+              <a:t>[Sources]</a:t>
+            </a:r>
+            <a:endParaRPr lang="en-US" dirty="0"/>
+          </a:p>
+          <a:p>
+            <a:r>
+              <a:rPr lang="en-US" dirty="0"/>
+              <a:t>- SlideCraft 0.4 release notes and test suite — Oct 2026 — https://github.com/eiler2005/slidecraft/blob/main/CHANGELOG.md</a:t>
             </a:r>
             <a:endParaRPr lang="en-US" dirty="0"/>
           </a:p>
@@ -1481,7 +1495,21 @@
           <a:p>
             <a:r>
               <a:rPr lang="en-US" dirty="0"/>
-              <a:t/>
+              <a:t>[Sources]</a:t>
+            </a:r>
+            <a:endParaRPr lang="en-US" dirty="0"/>
+          </a:p>
+          <a:p>
+            <a:r>
+              <a:rPr lang="en-US" dirty="0"/>
+              <a:t>- SlideCraft calibration against Microsoft PowerPoint, 144 strings — Oct 2026 — https://github.com/eiler2005/slidecraft/blob/main/docs/how-to/apply-brand.md</a:t>
+            </a:r>
+            <a:endParaRPr lang="en-US" dirty="0"/>
+          </a:p>
+          <a:p>
+            <a:r>
+              <a:rPr lang="en-US" dirty="0"/>
+              <a:t>- SlideCraft 0.4 release notes and test suite — Oct 2026 — https://github.com/eiler2005/slidecraft/blob/main/CHANGELOG.md</a:t>
             </a:r>
             <a:endParaRPr lang="en-US" dirty="0"/>
           </a:p>
@@ -2269,7 +2297,7 @@
       </p:grpSpPr>
       <p:sp>
         <p:nvSpPr>
-          <p:cNvPr id="3" name="SlideCraft Title sc:cover/title"/>
+          <p:cNvPr id="9" name="SlideCraft Title sc:cover/title"/>
           <p:cNvSpPr>
             <a:spLocks xmlns:a="http://schemas.openxmlformats.org/drawingml/2006/main" noGrp="1"/>
           </p:cNvSpPr>
@@ -2280,7 +2308,7 @@
         <p:spPr>
           <a:xfrm>
             <a:off x="822960" y="2011680"/>
-            <a:ext cx="8046519" cy="2148840"/>
+            <a:ext cx="5432424" cy="2148840"/>
           </a:xfrm>
           <a:prstGeom prst="rect">
             <a:avLst/>
@@ -2322,14 +2350,269 @@
       </p:sp>
       <p:sp>
         <p:nvSpPr>
-          <p:cNvPr id="2" name="sc:cover/kicker"/>
+          <p:cNvPr id="2" name="Shape 0"/>
+          <p:cNvSpPr/>
+          <p:nvPr/>
+        </p:nvSpPr>
+        <p:spPr>
+          <a:xfrm>
+            <a:off x="8531352" y="0"/>
+            <a:ext cx="3660343" cy="6858000"/>
+          </a:xfrm>
+          <a:prstGeom prst="rect">
+            <a:avLst/>
+          </a:prstGeom>
+          <a:solidFill>
+            <a:srgbClr val="1F5FBF"/>
+          </a:solidFill>
+          <a:ln/>
+        </p:spPr>
+      </p:sp>
+      <p:sp>
+        <p:nvSpPr>
+          <p:cNvPr id="3" name="Shape 1"/>
+          <p:cNvSpPr/>
+          <p:nvPr/>
+        </p:nvSpPr>
+        <p:spPr>
+          <a:xfrm>
+            <a:off x="9129447" y="640080"/>
+            <a:ext cx="2213159" cy="1027786"/>
+          </a:xfrm>
+          <a:custGeom>
+            <a:avLst/>
+            <a:gdLst/>
+            <a:ahLst/>
+            <a:cxnLst/>
+            <a:rect l="l" t="t" r="r" b="b"/>
+            <a:pathLst>
+              <a:path w="2213159" h="1027786">
+                <a:moveTo>
+                  <a:pt x="0" y="0"/>
+                </a:moveTo>
+                <a:lnTo>
+                  <a:pt x="1106579" y="462504"/>
+                </a:lnTo>
+                <a:lnTo>
+                  <a:pt x="2213159" y="0"/>
+                </a:lnTo>
+                <a:lnTo>
+                  <a:pt x="2213159" y="565282"/>
+                </a:lnTo>
+                <a:lnTo>
+                  <a:pt x="1106579" y="1027786"/>
+                </a:lnTo>
+                <a:lnTo>
+                  <a:pt x="0" y="565282"/>
+                </a:lnTo>
+                <a:close/>
+              </a:path>
+            </a:pathLst>
+          </a:custGeom>
+          <a:solidFill>
+            <a:srgbClr val="5787CF"/>
+          </a:solidFill>
+          <a:ln/>
+        </p:spPr>
+      </p:sp>
+      <p:sp>
+        <p:nvSpPr>
+          <p:cNvPr id="4" name="Shape 2"/>
+          <p:cNvSpPr/>
+          <p:nvPr/>
+        </p:nvSpPr>
+        <p:spPr>
+          <a:xfrm>
+            <a:off x="9500864" y="1777594"/>
+            <a:ext cx="2213159" cy="1027786"/>
+          </a:xfrm>
+          <a:custGeom>
+            <a:avLst/>
+            <a:gdLst/>
+            <a:ahLst/>
+            <a:cxnLst/>
+            <a:rect l="l" t="t" r="r" b="b"/>
+            <a:pathLst>
+              <a:path w="2213159" h="1027786">
+                <a:moveTo>
+                  <a:pt x="0" y="0"/>
+                </a:moveTo>
+                <a:lnTo>
+                  <a:pt x="1106579" y="462504"/>
+                </a:lnTo>
+                <a:lnTo>
+                  <a:pt x="2213159" y="0"/>
+                </a:lnTo>
+                <a:lnTo>
+                  <a:pt x="2213159" y="565282"/>
+                </a:lnTo>
+                <a:lnTo>
+                  <a:pt x="1106579" y="1027786"/>
+                </a:lnTo>
+                <a:lnTo>
+                  <a:pt x="0" y="565282"/>
+                </a:lnTo>
+                <a:close/>
+              </a:path>
+            </a:pathLst>
+          </a:custGeom>
+          <a:solidFill>
+            <a:srgbClr val="6D97D5"/>
+          </a:solidFill>
+          <a:ln/>
+        </p:spPr>
+      </p:sp>
+      <p:sp>
+        <p:nvSpPr>
+          <p:cNvPr id="5" name="Shape 3"/>
+          <p:cNvSpPr/>
+          <p:nvPr/>
+        </p:nvSpPr>
+        <p:spPr>
+          <a:xfrm>
+            <a:off x="9012736" y="2915107"/>
+            <a:ext cx="2213159" cy="1027786"/>
+          </a:xfrm>
+          <a:custGeom>
+            <a:avLst/>
+            <a:gdLst/>
+            <a:ahLst/>
+            <a:cxnLst/>
+            <a:rect l="l" t="t" r="r" b="b"/>
+            <a:pathLst>
+              <a:path w="2213159" h="1027786">
+                <a:moveTo>
+                  <a:pt x="0" y="0"/>
+                </a:moveTo>
+                <a:lnTo>
+                  <a:pt x="1106579" y="462504"/>
+                </a:lnTo>
+                <a:lnTo>
+                  <a:pt x="2213159" y="0"/>
+                </a:lnTo>
+                <a:lnTo>
+                  <a:pt x="2213159" y="565282"/>
+                </a:lnTo>
+                <a:lnTo>
+                  <a:pt x="1106579" y="1027786"/>
+                </a:lnTo>
+                <a:lnTo>
+                  <a:pt x="0" y="565282"/>
+                </a:lnTo>
+                <a:close/>
+              </a:path>
+            </a:pathLst>
+          </a:custGeom>
+          <a:solidFill>
+            <a:srgbClr val="84A7DC"/>
+          </a:solidFill>
+          <a:ln/>
+        </p:spPr>
+      </p:sp>
+      <p:sp>
+        <p:nvSpPr>
+          <p:cNvPr id="6" name="Shape 4"/>
+          <p:cNvSpPr/>
+          <p:nvPr/>
+        </p:nvSpPr>
+        <p:spPr>
+          <a:xfrm>
+            <a:off x="9421356" y="4052621"/>
+            <a:ext cx="2213159" cy="1027786"/>
+          </a:xfrm>
+          <a:custGeom>
+            <a:avLst/>
+            <a:gdLst/>
+            <a:ahLst/>
+            <a:cxnLst/>
+            <a:rect l="l" t="t" r="r" b="b"/>
+            <a:pathLst>
+              <a:path w="2213159" h="1027786">
+                <a:moveTo>
+                  <a:pt x="0" y="0"/>
+                </a:moveTo>
+                <a:lnTo>
+                  <a:pt x="1106579" y="462504"/>
+                </a:lnTo>
+                <a:lnTo>
+                  <a:pt x="2213159" y="0"/>
+                </a:lnTo>
+                <a:lnTo>
+                  <a:pt x="2213159" y="565282"/>
+                </a:lnTo>
+                <a:lnTo>
+                  <a:pt x="1106579" y="1027786"/>
+                </a:lnTo>
+                <a:lnTo>
+                  <a:pt x="0" y="565282"/>
+                </a:lnTo>
+                <a:close/>
+              </a:path>
+            </a:pathLst>
+          </a:custGeom>
+          <a:solidFill>
+            <a:srgbClr val="FFFFFF"/>
+          </a:solidFill>
+          <a:ln/>
+        </p:spPr>
+      </p:sp>
+      <p:sp>
+        <p:nvSpPr>
+          <p:cNvPr id="7" name="Shape 5"/>
+          <p:cNvSpPr/>
+          <p:nvPr/>
+        </p:nvSpPr>
+        <p:spPr>
+          <a:xfrm>
+            <a:off x="9116112" y="5190134"/>
+            <a:ext cx="2213159" cy="1027786"/>
+          </a:xfrm>
+          <a:custGeom>
+            <a:avLst/>
+            <a:gdLst/>
+            <a:ahLst/>
+            <a:cxnLst/>
+            <a:rect l="l" t="t" r="r" b="b"/>
+            <a:pathLst>
+              <a:path w="2213159" h="1027786">
+                <a:moveTo>
+                  <a:pt x="0" y="0"/>
+                </a:moveTo>
+                <a:lnTo>
+                  <a:pt x="1106579" y="462504"/>
+                </a:lnTo>
+                <a:lnTo>
+                  <a:pt x="2213159" y="0"/>
+                </a:lnTo>
+                <a:lnTo>
+                  <a:pt x="2213159" y="565282"/>
+                </a:lnTo>
+                <a:lnTo>
+                  <a:pt x="1106579" y="1027786"/>
+                </a:lnTo>
+                <a:lnTo>
+                  <a:pt x="0" y="565282"/>
+                </a:lnTo>
+                <a:close/>
+              </a:path>
+            </a:pathLst>
+          </a:custGeom>
+          <a:solidFill>
+            <a:srgbClr val="B1C7E9"/>
+          </a:solidFill>
+          <a:ln/>
+        </p:spPr>
+      </p:sp>
+      <p:sp>
+        <p:nvSpPr>
+          <p:cNvPr id="8" name="sc:cover/kicker"/>
           <p:cNvSpPr txBox="1"/>
           <p:nvPr/>
         </p:nvSpPr>
         <p:spPr>
           <a:xfrm>
             <a:off x="822960" y="1600200"/>
-            <a:ext cx="8046519" cy="274320"/>
+            <a:ext cx="7342632" cy="274320"/>
           </a:xfrm>
           <a:prstGeom prst="rect">
             <a:avLst/>
@@ -2371,14 +2654,14 @@
       </p:sp>
       <p:sp>
         <p:nvSpPr>
-          <p:cNvPr id="4" name="sc:cover/subtitle"/>
+          <p:cNvPr id="10" name="sc:cover/subtitle"/>
           <p:cNvSpPr txBox="1"/>
           <p:nvPr/>
         </p:nvSpPr>
         <p:spPr>
           <a:xfrm>
-            <a:off x="822960" y="3383280"/>
-            <a:ext cx="8046519" cy="822960"/>
+            <a:off x="822960" y="3931920"/>
+            <a:ext cx="7342632" cy="822960"/>
           </a:xfrm>
           <a:prstGeom prst="rect">
             <a:avLst/>
@@ -2420,7 +2703,7 @@
       </p:sp>
       <p:sp>
         <p:nvSpPr>
-          <p:cNvPr id="5" name="Shape 3"/>
+          <p:cNvPr id="11" name="Shape 9"/>
           <p:cNvSpPr/>
           <p:nvPr/>
         </p:nvSpPr>
@@ -2457,14 +2740,14 @@
       </p:sp>
       <p:sp>
         <p:nvSpPr>
-          <p:cNvPr id="6" name="sc:cover/presenter"/>
+          <p:cNvPr id="12" name="sc:cover/presenter"/>
           <p:cNvSpPr txBox="1"/>
           <p:nvPr/>
         </p:nvSpPr>
         <p:spPr>
           <a:xfrm>
             <a:off x="822960" y="5833872"/>
-            <a:ext cx="8046519" cy="274320"/>
+            <a:ext cx="7342632" cy="274320"/>
           </a:xfrm>
           <a:prstGeom prst="rect">
             <a:avLst/>

</xml_diff>

<commit_message>
chore(release): prepare SlideCraft 0.8.0
</commit_message>
<xml_diff>
--- a/docs/showcase/slidecraft-overview.pptx
+++ b/docs/showcase/slidecraft-overview.pptx
@@ -1312,7 +1312,7 @@
           <a:p>
             <a:r>
               <a:rPr lang="en-US" dirty="0"/>
-              <a:t>- SlideCraft 0.4 release notes and test suite — Oct 2026 — https://github.com/eiler2005/slidecraft/blob/main/CHANGELOG.md</a:t>
+              <a:t>- SlideCraft 0.8 release notes and layout registry — Oct 2026 — https://github.com/eiler2005/slidecraft/blob/main/CHANGELOG.md</a:t>
             </a:r>
             <a:endParaRPr lang="en-US" dirty="0"/>
           </a:p>
@@ -1407,7 +1407,7 @@
           <a:p>
             <a:r>
               <a:rPr lang="en-US" dirty="0"/>
-              <a:t>- SlideCraft 0.4 release notes and test suite — Oct 2026 — https://github.com/eiler2005/slidecraft/blob/main/CHANGELOG.md</a:t>
+              <a:t>- SlideCraft 0.8 release notes and layout registry — Oct 2026 — https://github.com/eiler2005/slidecraft/blob/main/CHANGELOG.md</a:t>
             </a:r>
             <a:endParaRPr lang="en-US" dirty="0"/>
           </a:p>
@@ -1509,7 +1509,7 @@
           <a:p>
             <a:r>
               <a:rPr lang="en-US" dirty="0"/>
-              <a:t>- SlideCraft 0.4 release notes and test suite — Oct 2026 — https://github.com/eiler2005/slidecraft/blob/main/CHANGELOG.md</a:t>
+              <a:t>- SlideCraft 0.8 release notes and layout registry — Oct 2026 — https://github.com/eiler2005/slidecraft/blob/main/CHANGELOG.md</a:t>
             </a:r>
             <a:endParaRPr lang="en-US" dirty="0"/>
           </a:p>
@@ -9436,7 +9436,7 @@
                   </a:extLst>
                 </a:hlinkClick>
               </a:rPr>
-              <a:t>SlideCraft 0.4 release notes and test suite (Oct 2026)</a:t>
+              <a:t>SlideCraft 0.8 release notes and layout registry (Oct 2026)</a:t>
             </a:r>
             <a:endParaRPr lang="en-US" sz="800" u="sng" dirty="0" kern="400000">
               <a:solidFill>
@@ -9956,7 +9956,7 @@
                 <a:ea typeface="Arial" pitchFamily="34" charset="-122"/>
                 <a:cs typeface="Arial" pitchFamily="34" charset="-120"/>
               </a:rPr>
-              <a:t>32</a:t>
+              <a:t>73</a:t>
             </a:r>
             <a:endParaRPr lang="en-US" sz="5400" b="1" dirty="0" kern="400000">
               <a:solidFill>
@@ -10042,7 +10042,7 @@
                 <a:ea typeface="Arial" pitchFamily="34" charset="-122"/>
                 <a:cs typeface="Arial" pitchFamily="34" charset="-120"/>
               </a:rPr>
-              <a:t>From executive summaries to waterfalls, risk matrices and org charts</a:t>
+              <a:t>From executive summaries to charts, architecture and editable diagrams</a:t>
             </a:r>
             <a:endParaRPr lang="en-US" sz="1000" dirty="0" kern="400000">
               <a:solidFill>
@@ -10226,7 +10226,7 @@
                 <a:ea typeface="Arial" pitchFamily="34" charset="-122"/>
                 <a:cs typeface="Arial" pitchFamily="34" charset="-120"/>
               </a:rPr>
-              <a:t>6</a:t>
+              <a:t>7</a:t>
             </a:r>
             <a:endParaRPr lang="en-US" sz="5400" b="1" dirty="0" kern="400000">
               <a:solidFill>
@@ -10520,7 +10520,7 @@
                   </a:extLst>
                 </a:hlinkClick>
               </a:rPr>
-              <a:t>SlideCraft 0.4 release notes and test suite (Oct 2026)</a:t>
+              <a:t>SlideCraft 0.8 release notes and layout registry (Oct 2026)</a:t>
             </a:r>
             <a:endParaRPr lang="en-US" sz="800" u="sng" dirty="0" kern="400000">
               <a:solidFill>
@@ -12379,7 +12379,7 @@
                   </a:extLst>
                 </a:hlinkClick>
               </a:rPr>
-              <a:t>SlideCraft 0.4 release notes and test suite (Oct 2026)</a:t>
+              <a:t>SlideCraft 0.8 release notes and layout registry (Oct 2026)</a:t>
             </a:r>
             <a:endParaRPr lang="en-US" sz="800" u="sng" dirty="0" kern="400000">
               <a:solidFill>

</xml_diff>